<commit_message>
Speaker script, in the deck and on paper
speaker_notes.py writes the spoken script into the PowerPoint notes, where
presenter view shows it, and into results/speaker_notes.docx for reading on
paper. 12m35s of speaking across 14 slides, plus prepared answers to the seven
questions the work most obviously invites - training length, the FPS view
selection, the single model family, three seeds, why pose-guided is worst, how
the numbers are checked, and what more compute would buy.

Notes are matched to slides by TITLE rather than by index. Matching on index
means inserting one slide in build_slides.py shifts every note after it by one,
and nothing would report that - it would surface in the exam. A note matching
no slide, or a slide with no note, is printed instead.
</commit_message>
<xml_diff>
--- a/results/presentation.pptx
+++ b/results/presentation.pptx
@@ -118,6 +118,1631 @@
     </a:lvl9pPr>
   </p:defaultTextStyle>
 </p:presentation>
+</file>
+
+<file path=ppt/notesMasters/notesMaster1.xml><?xml version="1.0" encoding="utf-8"?>
+<p:notesMaster xmlns:a="http://schemas.openxmlformats.org/drawingml/2006/main" xmlns:p="http://schemas.openxmlformats.org/presentationml/2006/main" xmlns:r="http://schemas.openxmlformats.org/officeDocument/2006/relationships">
+  <p:cSld>
+    <p:bg>
+      <p:bgRef idx="1001">
+        <a:schemeClr val="bg1"/>
+      </p:bgRef>
+    </p:bg>
+    <p:spTree>
+      <p:nvGrpSpPr>
+        <p:cNvPr id="1" name=""/>
+        <p:cNvGrpSpPr/>
+        <p:nvPr/>
+      </p:nvGrpSpPr>
+      <p:grpSpPr>
+        <a:xfrm>
+          <a:off x="0" y="0"/>
+          <a:ext cx="0" cy="0"/>
+          <a:chOff x="0" y="0"/>
+          <a:chExt cx="0" cy="0"/>
+        </a:xfrm>
+      </p:grpSpPr>
+      <p:sp>
+        <p:nvSpPr>
+          <p:cNvPr id="2" name="Header Placeholder 1"/>
+          <p:cNvSpPr>
+            <a:spLocks noGrp="1"/>
+          </p:cNvSpPr>
+          <p:nvPr>
+            <p:ph type="hdr" sz="quarter"/>
+          </p:nvPr>
+        </p:nvSpPr>
+        <p:spPr>
+          <a:xfrm>
+            <a:off x="0" y="0"/>
+            <a:ext cx="2971800" cy="457200"/>
+          </a:xfrm>
+          <a:prstGeom prst="rect">
+            <a:avLst/>
+          </a:prstGeom>
+        </p:spPr>
+        <p:txBody>
+          <a:bodyPr vert="horz" lIns="91440" tIns="45720" rIns="91440" bIns="45720" rtlCol="0"/>
+          <a:lstStyle>
+            <a:lvl1pPr algn="l">
+              <a:defRPr sz="1200"/>
+            </a:lvl1pPr>
+          </a:lstStyle>
+          <a:p>
+            <a:endParaRPr lang="en-US"/>
+          </a:p>
+        </p:txBody>
+      </p:sp>
+      <p:sp>
+        <p:nvSpPr>
+          <p:cNvPr id="3" name="Date Placeholder 2"/>
+          <p:cNvSpPr>
+            <a:spLocks noGrp="1"/>
+          </p:cNvSpPr>
+          <p:nvPr>
+            <p:ph type="dt" idx="1"/>
+          </p:nvPr>
+        </p:nvSpPr>
+        <p:spPr>
+          <a:xfrm>
+            <a:off x="3884613" y="0"/>
+            <a:ext cx="2971800" cy="457200"/>
+          </a:xfrm>
+          <a:prstGeom prst="rect">
+            <a:avLst/>
+          </a:prstGeom>
+        </p:spPr>
+        <p:txBody>
+          <a:bodyPr vert="horz" lIns="91440" tIns="45720" rIns="91440" bIns="45720" rtlCol="0"/>
+          <a:lstStyle>
+            <a:lvl1pPr algn="r">
+              <a:defRPr sz="1200"/>
+            </a:lvl1pPr>
+          </a:lstStyle>
+          <a:p>
+            <a:fld id="{0F89C1C7-3DCD-1040-A9CF-14679D8B5DDD}" type="datetimeFigureOut">
+              <a:rPr lang="en-US" smtClean="0"/>
+              <a:t>10/17/16</a:t>
+            </a:fld>
+            <a:endParaRPr lang="en-US"/>
+          </a:p>
+        </p:txBody>
+      </p:sp>
+      <p:sp>
+        <p:nvSpPr>
+          <p:cNvPr id="4" name="Slide Image Placeholder 3"/>
+          <p:cNvSpPr>
+            <a:spLocks noGrp="1" noRot="1" noChangeAspect="1"/>
+          </p:cNvSpPr>
+          <p:nvPr>
+            <p:ph type="sldImg" idx="2"/>
+          </p:nvPr>
+        </p:nvSpPr>
+        <p:spPr>
+          <a:xfrm>
+            <a:off x="1143000" y="685800"/>
+            <a:ext cx="4572000" cy="3429000"/>
+          </a:xfrm>
+          <a:prstGeom prst="rect">
+            <a:avLst/>
+          </a:prstGeom>
+          <a:noFill/>
+          <a:ln w="12700">
+            <a:solidFill>
+              <a:prstClr val="black"/>
+            </a:solidFill>
+          </a:ln>
+        </p:spPr>
+        <p:txBody>
+          <a:bodyPr vert="horz" lIns="91440" tIns="45720" rIns="91440" bIns="45720" rtlCol="0" anchor="ctr"/>
+          <a:lstStyle/>
+          <a:p>
+            <a:endParaRPr lang="en-US"/>
+          </a:p>
+        </p:txBody>
+      </p:sp>
+      <p:sp>
+        <p:nvSpPr>
+          <p:cNvPr id="5" name="Notes Placeholder 4"/>
+          <p:cNvSpPr>
+            <a:spLocks noGrp="1"/>
+          </p:cNvSpPr>
+          <p:nvPr>
+            <p:ph type="body" sz="quarter" idx="3"/>
+          </p:nvPr>
+        </p:nvSpPr>
+        <p:spPr>
+          <a:xfrm>
+            <a:off x="685800" y="4343400"/>
+            <a:ext cx="5486400" cy="4114800"/>
+          </a:xfrm>
+          <a:prstGeom prst="rect">
+            <a:avLst/>
+          </a:prstGeom>
+        </p:spPr>
+        <p:txBody>
+          <a:bodyPr vert="horz" lIns="91440" tIns="45720" rIns="91440" bIns="45720" rtlCol="0"/>
+          <a:lstStyle/>
+          <a:p>
+            <a:pPr lvl="0"/>
+            <a:r>
+              <a:rPr lang="en-US" smtClean="0"/>
+              <a:t>Click to edit Master text styles</a:t>
+            </a:r>
+          </a:p>
+          <a:p>
+            <a:pPr lvl="1"/>
+            <a:r>
+              <a:rPr lang="en-US" smtClean="0"/>
+              <a:t>Second level</a:t>
+            </a:r>
+          </a:p>
+          <a:p>
+            <a:pPr lvl="2"/>
+            <a:r>
+              <a:rPr lang="en-US" smtClean="0"/>
+              <a:t>Third level</a:t>
+            </a:r>
+          </a:p>
+          <a:p>
+            <a:pPr lvl="3"/>
+            <a:r>
+              <a:rPr lang="en-US" smtClean="0"/>
+              <a:t>Fourth level</a:t>
+            </a:r>
+          </a:p>
+          <a:p>
+            <a:pPr lvl="4"/>
+            <a:r>
+              <a:rPr lang="en-US" smtClean="0"/>
+              <a:t>Fifth level</a:t>
+            </a:r>
+            <a:endParaRPr lang="en-US"/>
+          </a:p>
+        </p:txBody>
+      </p:sp>
+      <p:sp>
+        <p:nvSpPr>
+          <p:cNvPr id="6" name="Footer Placeholder 5"/>
+          <p:cNvSpPr>
+            <a:spLocks noGrp="1"/>
+          </p:cNvSpPr>
+          <p:nvPr>
+            <p:ph type="ftr" sz="quarter" idx="4"/>
+          </p:nvPr>
+        </p:nvSpPr>
+        <p:spPr>
+          <a:xfrm>
+            <a:off x="0" y="8685213"/>
+            <a:ext cx="2971800" cy="457200"/>
+          </a:xfrm>
+          <a:prstGeom prst="rect">
+            <a:avLst/>
+          </a:prstGeom>
+        </p:spPr>
+        <p:txBody>
+          <a:bodyPr vert="horz" lIns="91440" tIns="45720" rIns="91440" bIns="45720" rtlCol="0" anchor="b"/>
+          <a:lstStyle>
+            <a:lvl1pPr algn="l">
+              <a:defRPr sz="1200"/>
+            </a:lvl1pPr>
+          </a:lstStyle>
+          <a:p>
+            <a:endParaRPr lang="en-US"/>
+          </a:p>
+        </p:txBody>
+      </p:sp>
+      <p:sp>
+        <p:nvSpPr>
+          <p:cNvPr id="7" name="Slide Number Placeholder 6"/>
+          <p:cNvSpPr>
+            <a:spLocks noGrp="1"/>
+          </p:cNvSpPr>
+          <p:nvPr>
+            <p:ph type="sldNum" sz="quarter" idx="5"/>
+          </p:nvPr>
+        </p:nvSpPr>
+        <p:spPr>
+          <a:xfrm>
+            <a:off x="3884613" y="8685213"/>
+            <a:ext cx="2971800" cy="457200"/>
+          </a:xfrm>
+          <a:prstGeom prst="rect">
+            <a:avLst/>
+          </a:prstGeom>
+        </p:spPr>
+        <p:txBody>
+          <a:bodyPr vert="horz" lIns="91440" tIns="45720" rIns="91440" bIns="45720" rtlCol="0" anchor="b"/>
+          <a:lstStyle>
+            <a:lvl1pPr algn="r">
+              <a:defRPr sz="1200"/>
+            </a:lvl1pPr>
+          </a:lstStyle>
+          <a:p>
+            <a:fld id="{BB5E49A5-4136-284D-997B-48E1D791AD67}" type="slidenum">
+              <a:rPr lang="en-US" smtClean="0"/>
+              <a:t>‹#›</a:t>
+            </a:fld>
+            <a:endParaRPr lang="en-US"/>
+          </a:p>
+        </p:txBody>
+      </p:sp>
+    </p:spTree>
+    <p:extLst>
+      <p:ext uri="{BB962C8B-B14F-4D97-AF65-F5344CB8AC3E}">
+        <p14:creationId xmlns:p14="http://schemas.microsoft.com/office/powerpoint/2010/main" val="2623252185"/>
+      </p:ext>
+    </p:extLst>
+  </p:cSld>
+  <p:clrMap bg1="lt1" tx1="dk1" bg2="lt2" tx2="dk2" accent1="accent1" accent2="accent2" accent3="accent3" accent4="accent4" accent5="accent5" accent6="accent6" hlink="hlink" folHlink="folHlink"/>
+  <p:notesStyle>
+    <a:lvl1pPr marL="0" algn="l" defTabSz="457200" rtl="0" eaLnBrk="1" latinLnBrk="0" hangingPunct="1">
+      <a:defRPr sz="1200" kern="1200">
+        <a:solidFill>
+          <a:schemeClr val="tx1"/>
+        </a:solidFill>
+        <a:latin typeface="+mn-lt"/>
+        <a:ea typeface="+mn-ea"/>
+        <a:cs typeface="+mn-cs"/>
+      </a:defRPr>
+    </a:lvl1pPr>
+    <a:lvl2pPr marL="457200" algn="l" defTabSz="457200" rtl="0" eaLnBrk="1" latinLnBrk="0" hangingPunct="1">
+      <a:defRPr sz="1200" kern="1200">
+        <a:solidFill>
+          <a:schemeClr val="tx1"/>
+        </a:solidFill>
+        <a:latin typeface="+mn-lt"/>
+        <a:ea typeface="+mn-ea"/>
+        <a:cs typeface="+mn-cs"/>
+      </a:defRPr>
+    </a:lvl2pPr>
+    <a:lvl3pPr marL="914400" algn="l" defTabSz="457200" rtl="0" eaLnBrk="1" latinLnBrk="0" hangingPunct="1">
+      <a:defRPr sz="1200" kern="1200">
+        <a:solidFill>
+          <a:schemeClr val="tx1"/>
+        </a:solidFill>
+        <a:latin typeface="+mn-lt"/>
+        <a:ea typeface="+mn-ea"/>
+        <a:cs typeface="+mn-cs"/>
+      </a:defRPr>
+    </a:lvl3pPr>
+    <a:lvl4pPr marL="1371600" algn="l" defTabSz="457200" rtl="0" eaLnBrk="1" latinLnBrk="0" hangingPunct="1">
+      <a:defRPr sz="1200" kern="1200">
+        <a:solidFill>
+          <a:schemeClr val="tx1"/>
+        </a:solidFill>
+        <a:latin typeface="+mn-lt"/>
+        <a:ea typeface="+mn-ea"/>
+        <a:cs typeface="+mn-cs"/>
+      </a:defRPr>
+    </a:lvl4pPr>
+    <a:lvl5pPr marL="1828800" algn="l" defTabSz="457200" rtl="0" eaLnBrk="1" latinLnBrk="0" hangingPunct="1">
+      <a:defRPr sz="1200" kern="1200">
+        <a:solidFill>
+          <a:schemeClr val="tx1"/>
+        </a:solidFill>
+        <a:latin typeface="+mn-lt"/>
+        <a:ea typeface="+mn-ea"/>
+        <a:cs typeface="+mn-cs"/>
+      </a:defRPr>
+    </a:lvl5pPr>
+    <a:lvl6pPr marL="2286000" algn="l" defTabSz="457200" rtl="0" eaLnBrk="1" latinLnBrk="0" hangingPunct="1">
+      <a:defRPr sz="1200" kern="1200">
+        <a:solidFill>
+          <a:schemeClr val="tx1"/>
+        </a:solidFill>
+        <a:latin typeface="+mn-lt"/>
+        <a:ea typeface="+mn-ea"/>
+        <a:cs typeface="+mn-cs"/>
+      </a:defRPr>
+    </a:lvl6pPr>
+    <a:lvl7pPr marL="2743200" algn="l" defTabSz="457200" rtl="0" eaLnBrk="1" latinLnBrk="0" hangingPunct="1">
+      <a:defRPr sz="1200" kern="1200">
+        <a:solidFill>
+          <a:schemeClr val="tx1"/>
+        </a:solidFill>
+        <a:latin typeface="+mn-lt"/>
+        <a:ea typeface="+mn-ea"/>
+        <a:cs typeface="+mn-cs"/>
+      </a:defRPr>
+    </a:lvl7pPr>
+    <a:lvl8pPr marL="3200400" algn="l" defTabSz="457200" rtl="0" eaLnBrk="1" latinLnBrk="0" hangingPunct="1">
+      <a:defRPr sz="1200" kern="1200">
+        <a:solidFill>
+          <a:schemeClr val="tx1"/>
+        </a:solidFill>
+        <a:latin typeface="+mn-lt"/>
+        <a:ea typeface="+mn-ea"/>
+        <a:cs typeface="+mn-cs"/>
+      </a:defRPr>
+    </a:lvl8pPr>
+    <a:lvl9pPr marL="3657600" algn="l" defTabSz="457200" rtl="0" eaLnBrk="1" latinLnBrk="0" hangingPunct="1">
+      <a:defRPr sz="1200" kern="1200">
+        <a:solidFill>
+          <a:schemeClr val="tx1"/>
+        </a:solidFill>
+        <a:latin typeface="+mn-lt"/>
+        <a:ea typeface="+mn-ea"/>
+        <a:cs typeface="+mn-cs"/>
+      </a:defRPr>
+    </a:lvl9pPr>
+  </p:notesStyle>
+</p:notesMaster>
+</file>
+
+<file path=ppt/notesSlides/notesSlide1.xml><?xml version="1.0" encoding="utf-8"?>
+<p:notes xmlns:a="http://schemas.openxmlformats.org/drawingml/2006/main" xmlns:p="http://schemas.openxmlformats.org/presentationml/2006/main" xmlns:r="http://schemas.openxmlformats.org/officeDocument/2006/relationships">
+  <p:cSld>
+    <p:spTree>
+      <p:nvGrpSpPr>
+        <p:cNvPr id="1" name=""/>
+        <p:cNvGrpSpPr/>
+        <p:nvPr/>
+      </p:nvGrpSpPr>
+      <p:grpSpPr>
+        <a:xfrm>
+          <a:off x="0" y="0"/>
+          <a:ext cx="0" cy="0"/>
+          <a:chOff x="0" y="0"/>
+          <a:chExt cx="0" cy="0"/>
+        </a:xfrm>
+      </p:grpSpPr>
+      <p:sp>
+        <p:nvSpPr>
+          <p:cNvPr id="2" name="Slide Image Placeholder 1"/>
+          <p:cNvSpPr>
+            <a:spLocks noGrp="1"/>
+          </p:cNvSpPr>
+          <p:nvPr>
+            <p:ph type="sldImg" idx="2"/>
+          </p:nvPr>
+        </p:nvSpPr>
+        <p:spPr/>
+      </p:sp>
+      <p:sp>
+        <p:nvSpPr>
+          <p:cNvPr id="3" name="Notes Placeholder 2"/>
+          <p:cNvSpPr>
+            <a:spLocks noGrp="1"/>
+          </p:cNvSpPr>
+          <p:nvPr>
+            <p:ph type="body" idx="3" sz="quarter"/>
+          </p:nvPr>
+        </p:nvSpPr>
+        <p:spPr/>
+        <p:txBody>
+          <a:bodyPr/>
+          <a:lstStyle/>
+          <a:p>
+            <a:r>
+              <a:t>[45s]</a:t>
+            </a:r>
+          </a:p>
+          <a:p>
+            <a:r>
+              <a:t>Good morning. My project asks one question: can AI-generated images replace photographs you never took, when you are reconstructing a 3D scene?</a:t>
+            </a:r>
+          </a:p>
+          <a:p>
+            <a:r>
+              <a:t>The short answer is yes, but only in a narrow window — and I spent most of the project working out where that window ends and why.</a:t>
+            </a:r>
+          </a:p>
+          <a:p>
+            <a:r>
+              <a:t>236 training runs, two scenes, and every number here is read straight out of the raw results files, not typed in by hand.</a:t>
+            </a:r>
+          </a:p>
+        </p:txBody>
+      </p:sp>
+      <p:sp>
+        <p:nvSpPr>
+          <p:cNvPr id="4" name="Slide Number Placeholder 3"/>
+          <p:cNvSpPr>
+            <a:spLocks noGrp="1"/>
+          </p:cNvSpPr>
+          <p:nvPr>
+            <p:ph type="sldNum" idx="5" sz="quarter"/>
+          </p:nvPr>
+        </p:nvSpPr>
+        <p:spPr/>
+      </p:sp>
+    </p:spTree>
+  </p:cSld>
+  <p:clrMapOvr>
+    <a:masterClrMapping/>
+  </p:clrMapOvr>
+</p:notes>
+</file>
+
+<file path=ppt/notesSlides/notesSlide10.xml><?xml version="1.0" encoding="utf-8"?>
+<p:notes xmlns:a="http://schemas.openxmlformats.org/drawingml/2006/main" xmlns:p="http://schemas.openxmlformats.org/presentationml/2006/main" xmlns:r="http://schemas.openxmlformats.org/officeDocument/2006/relationships">
+  <p:cSld>
+    <p:spTree>
+      <p:nvGrpSpPr>
+        <p:cNvPr id="1" name=""/>
+        <p:cNvGrpSpPr/>
+        <p:nvPr/>
+      </p:nvGrpSpPr>
+      <p:grpSpPr>
+        <a:xfrm>
+          <a:off x="0" y="0"/>
+          <a:ext cx="0" cy="0"/>
+          <a:chOff x="0" y="0"/>
+          <a:chExt cx="0" cy="0"/>
+        </a:xfrm>
+      </p:grpSpPr>
+      <p:sp>
+        <p:nvSpPr>
+          <p:cNvPr id="2" name="Slide Image Placeholder 1"/>
+          <p:cNvSpPr>
+            <a:spLocks noGrp="1"/>
+          </p:cNvSpPr>
+          <p:nvPr>
+            <p:ph type="sldImg" idx="2"/>
+          </p:nvPr>
+        </p:nvSpPr>
+        <p:spPr/>
+      </p:sp>
+      <p:sp>
+        <p:nvSpPr>
+          <p:cNvPr id="3" name="Notes Placeholder 2"/>
+          <p:cNvSpPr>
+            <a:spLocks noGrp="1"/>
+          </p:cNvSpPr>
+          <p:nvPr>
+            <p:ph type="body" idx="3" sz="quarter"/>
+          </p:nvPr>
+        </p:nvSpPr>
+        <p:spPr/>
+        <p:txBody>
+          <a:bodyPr/>
+          <a:lstStyle/>
+          <a:p>
+            <a:r>
+              <a:t>[55s]</a:t>
+            </a:r>
+          </a:p>
+          <a:p>
+            <a:r>
+              <a:t>First objection: maybe this is a quirk of Stable Diffusion 1.5.</a:t>
+            </a:r>
+          </a:p>
+          <a:p>
+            <a:r>
+              <a:t>So I swapped in Dreamshaper-8 — same architecture, same memory budget, but tuned for better photorealism.</a:t>
+            </a:r>
+          </a:p>
+          <a:p>
+            <a:r>
+              <a:t>It reverses in the same place. Positive at five, negative at twenty.</a:t>
+            </a:r>
+          </a:p>
+          <a:p>
+            <a:r>
+              <a:t>And here is the interesting part: the better-looking model is WORSE at every subset size. It even crosses over earlier.</a:t>
+            </a:r>
+          </a:p>
+          <a:p>
+            <a:r>
+              <a:t>A model tuned to make each image individually more convincing has no reason to be more consistent BETWEEN images. Which is the point — what a synthetic view contributes is coverage, not photorealism.</a:t>
+            </a:r>
+          </a:p>
+        </p:txBody>
+      </p:sp>
+      <p:sp>
+        <p:nvSpPr>
+          <p:cNvPr id="4" name="Slide Number Placeholder 3"/>
+          <p:cNvSpPr>
+            <a:spLocks noGrp="1"/>
+          </p:cNvSpPr>
+          <p:nvPr>
+            <p:ph type="sldNum" idx="5" sz="quarter"/>
+          </p:nvPr>
+        </p:nvSpPr>
+        <p:spPr/>
+      </p:sp>
+    </p:spTree>
+  </p:cSld>
+  <p:clrMapOvr>
+    <a:masterClrMapping/>
+  </p:clrMapOvr>
+</p:notes>
+</file>
+
+<file path=ppt/notesSlides/notesSlide11.xml><?xml version="1.0" encoding="utf-8"?>
+<p:notes xmlns:a="http://schemas.openxmlformats.org/drawingml/2006/main" xmlns:p="http://schemas.openxmlformats.org/presentationml/2006/main" xmlns:r="http://schemas.openxmlformats.org/officeDocument/2006/relationships">
+  <p:cSld>
+    <p:spTree>
+      <p:nvGrpSpPr>
+        <p:cNvPr id="1" name=""/>
+        <p:cNvGrpSpPr/>
+        <p:nvPr/>
+      </p:nvGrpSpPr>
+      <p:grpSpPr>
+        <a:xfrm>
+          <a:off x="0" y="0"/>
+          <a:ext cx="0" cy="0"/>
+          <a:chOff x="0" y="0"/>
+          <a:chExt cx="0" cy="0"/>
+        </a:xfrm>
+      </p:grpSpPr>
+      <p:sp>
+        <p:nvSpPr>
+          <p:cNvPr id="2" name="Slide Image Placeholder 1"/>
+          <p:cNvSpPr>
+            <a:spLocks noGrp="1"/>
+          </p:cNvSpPr>
+          <p:nvPr>
+            <p:ph type="sldImg" idx="2"/>
+          </p:nvPr>
+        </p:nvSpPr>
+        <p:spPr/>
+      </p:sp>
+      <p:sp>
+        <p:nvSpPr>
+          <p:cNvPr id="3" name="Notes Placeholder 2"/>
+          <p:cNvSpPr>
+            <a:spLocks noGrp="1"/>
+          </p:cNvSpPr>
+          <p:nvPr>
+            <p:ph type="body" idx="3" sz="quarter"/>
+          </p:nvPr>
+        </p:nvSpPr>
+        <p:spPr/>
+        <p:txBody>
+          <a:bodyPr/>
+          <a:lstStyle/>
+          <a:p>
+            <a:r>
+              <a:t>[70s]</a:t>
+            </a:r>
+          </a:p>
+          <a:p>
+            <a:r>
+              <a:t>Second and sharper prediction.</a:t>
+            </a:r>
+          </a:p>
+          <a:p>
+            <a:r>
+              <a:t>If the harm comes from inventing a camera, then something that helps the geometry WITHOUT inventing a camera should never turn negative.</a:t>
+            </a:r>
+          </a:p>
+          <a:p>
+            <a:r>
+              <a:t>Depth regularisation is exactly that. A depth network predicts a depth map for each real photograph, anchored to true scale against the sparse reconstruction points. No camera is invented, no pixel is fabricated.</a:t>
+            </a:r>
+          </a:p>
+          <a:p>
+            <a:r>
+              <a:t>It is positive at every subset size — including twenty, where outpainting loses 0.6.</a:t>
+            </a:r>
+          </a:p>
+          <a:p>
+            <a:r>
+              <a:t>Coverage crosses over. Constraint does not. The two differ in exactly one respect, and it is the one the theory says matters.</a:t>
+            </a:r>
+          </a:p>
+          <a:p>
+            <a:r>
+              <a:t>And they compound: together at five views they reach 0.714 dB, the best result in the study — because they repair different deficiencies.</a:t>
+            </a:r>
+          </a:p>
+        </p:txBody>
+      </p:sp>
+      <p:sp>
+        <p:nvSpPr>
+          <p:cNvPr id="4" name="Slide Number Placeholder 3"/>
+          <p:cNvSpPr>
+            <a:spLocks noGrp="1"/>
+          </p:cNvSpPr>
+          <p:nvPr>
+            <p:ph type="sldNum" idx="5" sz="quarter"/>
+          </p:nvPr>
+        </p:nvSpPr>
+        <p:spPr/>
+      </p:sp>
+    </p:spTree>
+  </p:cSld>
+  <p:clrMapOvr>
+    <a:masterClrMapping/>
+  </p:clrMapOvr>
+</p:notes>
+</file>
+
+<file path=ppt/notesSlides/notesSlide12.xml><?xml version="1.0" encoding="utf-8"?>
+<p:notes xmlns:a="http://schemas.openxmlformats.org/drawingml/2006/main" xmlns:p="http://schemas.openxmlformats.org/presentationml/2006/main" xmlns:r="http://schemas.openxmlformats.org/officeDocument/2006/relationships">
+  <p:cSld>
+    <p:spTree>
+      <p:nvGrpSpPr>
+        <p:cNvPr id="1" name=""/>
+        <p:cNvGrpSpPr/>
+        <p:nvPr/>
+      </p:nvGrpSpPr>
+      <p:grpSpPr>
+        <a:xfrm>
+          <a:off x="0" y="0"/>
+          <a:ext cx="0" cy="0"/>
+          <a:chOff x="0" y="0"/>
+          <a:chExt cx="0" cy="0"/>
+        </a:xfrm>
+      </p:grpSpPr>
+      <p:sp>
+        <p:nvSpPr>
+          <p:cNvPr id="2" name="Slide Image Placeholder 1"/>
+          <p:cNvSpPr>
+            <a:spLocks noGrp="1"/>
+          </p:cNvSpPr>
+          <p:nvPr>
+            <p:ph type="sldImg" idx="2"/>
+          </p:nvPr>
+        </p:nvSpPr>
+        <p:spPr/>
+      </p:sp>
+      <p:sp>
+        <p:nvSpPr>
+          <p:cNvPr id="3" name="Notes Placeholder 2"/>
+          <p:cNvSpPr>
+            <a:spLocks noGrp="1"/>
+          </p:cNvSpPr>
+          <p:nvPr>
+            <p:ph type="body" idx="3" sz="quarter"/>
+          </p:nvPr>
+        </p:nvSpPr>
+        <p:spPr/>
+        <p:txBody>
+          <a:bodyPr/>
+          <a:lstStyle/>
+          <a:p>
+            <a:r>
+              <a:t>[50s]</a:t>
+            </a:r>
+          </a:p>
+          <a:p>
+            <a:r>
+              <a:t>So, four things.</a:t>
+            </a:r>
+          </a:p>
+          <a:p>
+            <a:r>
+              <a:t>Augmentation is not free coverage. It helps only in the single digits.</a:t>
+            </a:r>
+          </a:p>
+          <a:p>
+            <a:r>
+              <a:t>The mechanism is pose novelty — four controls rule out image quality, hole content, warping artifacts, and mere repetition.</a:t>
+            </a:r>
+          </a:p>
+          <a:p>
+            <a:r>
+              <a:t>Constraint beats invention.</a:t>
+            </a:r>
+          </a:p>
+          <a:p>
+            <a:r>
+              <a:t>And the two are separable, which is why combining them beats either alone.</a:t>
+            </a:r>
+          </a:p>
+          <a:p>
+            <a:r>
+              <a:t>Practically: below about ten real views, use it. Above that, go and take more photographs.</a:t>
+            </a:r>
+          </a:p>
+        </p:txBody>
+      </p:sp>
+      <p:sp>
+        <p:nvSpPr>
+          <p:cNvPr id="4" name="Slide Number Placeholder 3"/>
+          <p:cNvSpPr>
+            <a:spLocks noGrp="1"/>
+          </p:cNvSpPr>
+          <p:nvPr>
+            <p:ph type="sldNum" idx="5" sz="quarter"/>
+          </p:nvPr>
+        </p:nvSpPr>
+        <p:spPr/>
+      </p:sp>
+    </p:spTree>
+  </p:cSld>
+  <p:clrMapOvr>
+    <a:masterClrMapping/>
+  </p:clrMapOvr>
+</p:notes>
+</file>
+
+<file path=ppt/notesSlides/notesSlide13.xml><?xml version="1.0" encoding="utf-8"?>
+<p:notes xmlns:a="http://schemas.openxmlformats.org/drawingml/2006/main" xmlns:p="http://schemas.openxmlformats.org/presentationml/2006/main" xmlns:r="http://schemas.openxmlformats.org/officeDocument/2006/relationships">
+  <p:cSld>
+    <p:spTree>
+      <p:nvGrpSpPr>
+        <p:cNvPr id="1" name=""/>
+        <p:cNvGrpSpPr/>
+        <p:nvPr/>
+      </p:nvGrpSpPr>
+      <p:grpSpPr>
+        <a:xfrm>
+          <a:off x="0" y="0"/>
+          <a:ext cx="0" cy="0"/>
+          <a:chOff x="0" y="0"/>
+          <a:chExt cx="0" cy="0"/>
+        </a:xfrm>
+      </p:grpSpPr>
+      <p:sp>
+        <p:nvSpPr>
+          <p:cNvPr id="2" name="Slide Image Placeholder 1"/>
+          <p:cNvSpPr>
+            <a:spLocks noGrp="1"/>
+          </p:cNvSpPr>
+          <p:nvPr>
+            <p:ph type="sldImg" idx="2"/>
+          </p:nvPr>
+        </p:nvSpPr>
+        <p:spPr/>
+      </p:sp>
+      <p:sp>
+        <p:nvSpPr>
+          <p:cNvPr id="3" name="Notes Placeholder 2"/>
+          <p:cNvSpPr>
+            <a:spLocks noGrp="1"/>
+          </p:cNvSpPr>
+          <p:nvPr>
+            <p:ph type="body" idx="3" sz="quarter"/>
+          </p:nvPr>
+        </p:nvSpPr>
+        <p:spPr/>
+        <p:txBody>
+          <a:bodyPr/>
+          <a:lstStyle/>
+          <a:p>
+            <a:r>
+              <a:t>[60s]</a:t>
+            </a:r>
+          </a:p>
+          <a:p>
+            <a:r>
+              <a:t>The honest limits.</a:t>
+            </a:r>
+          </a:p>
+          <a:p>
+            <a:r>
+              <a:t>The biggest one is training length. I train for 7,000 iterations. At 30,000 the benefit disappears entirely.</a:t>
+            </a:r>
+          </a:p>
+          <a:p>
+            <a:r>
+              <a:t>But — and this is the point — the plain baselines get WORSE at 30,000 too. With five photos, long training memorises them instead of learning the scene. So 30,000 is not better converged, it is over-trained. Early stopping is the correct setting for few-shot, and the gain is conditional on it.</a:t>
+            </a:r>
+          </a:p>
+          <a:p>
+            <a:r>
+              <a:t>Three seeds is a consistency check, not a significance test. Both diffusion checkpoints share an architecture, because SDXL and FLUX do not fit in four gigabytes.</a:t>
+            </a:r>
+          </a:p>
+        </p:txBody>
+      </p:sp>
+      <p:sp>
+        <p:nvSpPr>
+          <p:cNvPr id="4" name="Slide Number Placeholder 3"/>
+          <p:cNvSpPr>
+            <a:spLocks noGrp="1"/>
+          </p:cNvSpPr>
+          <p:nvPr>
+            <p:ph type="sldNum" idx="5" sz="quarter"/>
+          </p:nvPr>
+        </p:nvSpPr>
+        <p:spPr/>
+      </p:sp>
+    </p:spTree>
+  </p:cSld>
+  <p:clrMapOvr>
+    <a:masterClrMapping/>
+  </p:clrMapOvr>
+</p:notes>
+</file>
+
+<file path=ppt/notesSlides/notesSlide14.xml><?xml version="1.0" encoding="utf-8"?>
+<p:notes xmlns:a="http://schemas.openxmlformats.org/drawingml/2006/main" xmlns:p="http://schemas.openxmlformats.org/presentationml/2006/main" xmlns:r="http://schemas.openxmlformats.org/officeDocument/2006/relationships">
+  <p:cSld>
+    <p:spTree>
+      <p:nvGrpSpPr>
+        <p:cNvPr id="1" name=""/>
+        <p:cNvGrpSpPr/>
+        <p:nvPr/>
+      </p:nvGrpSpPr>
+      <p:grpSpPr>
+        <a:xfrm>
+          <a:off x="0" y="0"/>
+          <a:ext cx="0" cy="0"/>
+          <a:chOff x="0" y="0"/>
+          <a:chExt cx="0" cy="0"/>
+        </a:xfrm>
+      </p:grpSpPr>
+      <p:sp>
+        <p:nvSpPr>
+          <p:cNvPr id="2" name="Slide Image Placeholder 1"/>
+          <p:cNvSpPr>
+            <a:spLocks noGrp="1"/>
+          </p:cNvSpPr>
+          <p:nvPr>
+            <p:ph type="sldImg" idx="2"/>
+          </p:nvPr>
+        </p:nvSpPr>
+        <p:spPr/>
+      </p:sp>
+      <p:sp>
+        <p:nvSpPr>
+          <p:cNvPr id="3" name="Notes Placeholder 2"/>
+          <p:cNvSpPr>
+            <a:spLocks noGrp="1"/>
+          </p:cNvSpPr>
+          <p:nvPr>
+            <p:ph type="body" idx="3" sz="quarter"/>
+          </p:nvPr>
+        </p:nvSpPr>
+        <p:spPr/>
+        <p:txBody>
+          <a:bodyPr/>
+          <a:lstStyle/>
+          <a:p>
+            <a:r>
+              <a:t>[35s]</a:t>
+            </a:r>
+          </a:p>
+          <a:p>
+            <a:r>
+              <a:t>To close.</a:t>
+            </a:r>
+          </a:p>
+          <a:p>
+            <a:r>
+              <a:t>Augmentation buys coverage and pays for it in consistency. Whether that trade is worth taking depends entirely on how scarce your real photographs are.</a:t>
+            </a:r>
+          </a:p>
+          <a:p>
+            <a:r>
+              <a:t>At five views, worth it. By twenty, the same treatment is actively harmful.</a:t>
+            </a:r>
+          </a:p>
+          <a:p>
+            <a:r>
+              <a:t>Thank you — happy to take questions.</a:t>
+            </a:r>
+          </a:p>
+        </p:txBody>
+      </p:sp>
+      <p:sp>
+        <p:nvSpPr>
+          <p:cNvPr id="4" name="Slide Number Placeholder 3"/>
+          <p:cNvSpPr>
+            <a:spLocks noGrp="1"/>
+          </p:cNvSpPr>
+          <p:nvPr>
+            <p:ph type="sldNum" idx="5" sz="quarter"/>
+          </p:nvPr>
+        </p:nvSpPr>
+        <p:spPr/>
+      </p:sp>
+    </p:spTree>
+  </p:cSld>
+  <p:clrMapOvr>
+    <a:masterClrMapping/>
+  </p:clrMapOvr>
+</p:notes>
+</file>
+
+<file path=ppt/notesSlides/notesSlide2.xml><?xml version="1.0" encoding="utf-8"?>
+<p:notes xmlns:a="http://schemas.openxmlformats.org/drawingml/2006/main" xmlns:p="http://schemas.openxmlformats.org/presentationml/2006/main" xmlns:r="http://schemas.openxmlformats.org/officeDocument/2006/relationships">
+  <p:cSld>
+    <p:spTree>
+      <p:nvGrpSpPr>
+        <p:cNvPr id="1" name=""/>
+        <p:cNvGrpSpPr/>
+        <p:nvPr/>
+      </p:nvGrpSpPr>
+      <p:grpSpPr>
+        <a:xfrm>
+          <a:off x="0" y="0"/>
+          <a:ext cx="0" cy="0"/>
+          <a:chOff x="0" y="0"/>
+          <a:chExt cx="0" cy="0"/>
+        </a:xfrm>
+      </p:grpSpPr>
+      <p:sp>
+        <p:nvSpPr>
+          <p:cNvPr id="2" name="Slide Image Placeholder 1"/>
+          <p:cNvSpPr>
+            <a:spLocks noGrp="1"/>
+          </p:cNvSpPr>
+          <p:nvPr>
+            <p:ph type="sldImg" idx="2"/>
+          </p:nvPr>
+        </p:nvSpPr>
+        <p:spPr/>
+      </p:sp>
+      <p:sp>
+        <p:nvSpPr>
+          <p:cNvPr id="3" name="Notes Placeholder 2"/>
+          <p:cNvSpPr>
+            <a:spLocks noGrp="1"/>
+          </p:cNvSpPr>
+          <p:nvPr>
+            <p:ph type="body" idx="3" sz="quarter"/>
+          </p:nvPr>
+        </p:nvSpPr>
+        <p:spPr/>
+        <p:txBody>
+          <a:bodyPr/>
+          <a:lstStyle/>
+          <a:p>
+            <a:r>
+              <a:t>[60s]</a:t>
+            </a:r>
+          </a:p>
+          <a:p>
+            <a:r>
+              <a:t>Gaussian Splatting reconstructs a 3D scene from photographs. Given enough of them it is excellent — 25.2 dB on this outdoor scene from 219 photos.</a:t>
+            </a:r>
+          </a:p>
+          <a:p>
+            <a:r>
+              <a:t>Cut it to five photos and it collapses to 15.2. That is a ten decibel gap.</a:t>
+            </a:r>
+          </a:p>
+          <a:p>
+            <a:r>
+              <a:t>Photographs are expensive to collect. A diffusion model generates images for free. So the question is whether free images can buy back that gap.</a:t>
+            </a:r>
+          </a:p>
+        </p:txBody>
+      </p:sp>
+      <p:sp>
+        <p:nvSpPr>
+          <p:cNvPr id="4" name="Slide Number Placeholder 3"/>
+          <p:cNvSpPr>
+            <a:spLocks noGrp="1"/>
+          </p:cNvSpPr>
+          <p:nvPr>
+            <p:ph type="sldNum" idx="5" sz="quarter"/>
+          </p:nvPr>
+        </p:nvSpPr>
+        <p:spPr/>
+      </p:sp>
+    </p:spTree>
+  </p:cSld>
+  <p:clrMapOvr>
+    <a:masterClrMapping/>
+  </p:clrMapOvr>
+</p:notes>
+</file>
+
+<file path=ppt/notesSlides/notesSlide3.xml><?xml version="1.0" encoding="utf-8"?>
+<p:notes xmlns:a="http://schemas.openxmlformats.org/drawingml/2006/main" xmlns:p="http://schemas.openxmlformats.org/presentationml/2006/main" xmlns:r="http://schemas.openxmlformats.org/officeDocument/2006/relationships">
+  <p:cSld>
+    <p:spTree>
+      <p:nvGrpSpPr>
+        <p:cNvPr id="1" name=""/>
+        <p:cNvGrpSpPr/>
+        <p:nvPr/>
+      </p:nvGrpSpPr>
+      <p:grpSpPr>
+        <a:xfrm>
+          <a:off x="0" y="0"/>
+          <a:ext cx="0" cy="0"/>
+          <a:chOff x="0" y="0"/>
+          <a:chExt cx="0" cy="0"/>
+        </a:xfrm>
+      </p:grpSpPr>
+      <p:sp>
+        <p:nvSpPr>
+          <p:cNvPr id="2" name="Slide Image Placeholder 1"/>
+          <p:cNvSpPr>
+            <a:spLocks noGrp="1"/>
+          </p:cNvSpPr>
+          <p:nvPr>
+            <p:ph type="sldImg" idx="2"/>
+          </p:nvPr>
+        </p:nvSpPr>
+        <p:spPr/>
+      </p:sp>
+      <p:sp>
+        <p:nvSpPr>
+          <p:cNvPr id="3" name="Notes Placeholder 2"/>
+          <p:cNvSpPr>
+            <a:spLocks noGrp="1"/>
+          </p:cNvSpPr>
+          <p:nvPr>
+            <p:ph type="body" idx="3" sz="quarter"/>
+          </p:nvPr>
+        </p:nvSpPr>
+        <p:spPr/>
+        <p:txBody>
+          <a:bodyPr/>
+          <a:lstStyle/>
+          <a:p>
+            <a:r>
+              <a:t>[40s]</a:t>
+            </a:r>
+          </a:p>
+          <a:p>
+            <a:r>
+              <a:t>This is the same held-out camera reconstructed from 5, 10, 20 and 219 photos.</a:t>
+            </a:r>
+          </a:p>
+          <a:p>
+            <a:r>
+              <a:t>The important thing is what fails at five views. The shape of the truck is broadly right. What costs the ten decibels is the haze, the floaters, and the surfaces the optimiser had no second view to pin down.</a:t>
+            </a:r>
+          </a:p>
+          <a:p>
+            <a:r>
+              <a:t>So the deficit is coverage, not detail. That matters later.</a:t>
+            </a:r>
+          </a:p>
+        </p:txBody>
+      </p:sp>
+      <p:sp>
+        <p:nvSpPr>
+          <p:cNvPr id="4" name="Slide Number Placeholder 3"/>
+          <p:cNvSpPr>
+            <a:spLocks noGrp="1"/>
+          </p:cNvSpPr>
+          <p:nvPr>
+            <p:ph type="sldNum" idx="5" sz="quarter"/>
+          </p:nvPr>
+        </p:nvSpPr>
+        <p:spPr/>
+      </p:sp>
+    </p:spTree>
+  </p:cSld>
+  <p:clrMapOvr>
+    <a:masterClrMapping/>
+  </p:clrMapOvr>
+</p:notes>
+</file>
+
+<file path=ppt/notesSlides/notesSlide4.xml><?xml version="1.0" encoding="utf-8"?>
+<p:notes xmlns:a="http://schemas.openxmlformats.org/drawingml/2006/main" xmlns:p="http://schemas.openxmlformats.org/presentationml/2006/main" xmlns:r="http://schemas.openxmlformats.org/officeDocument/2006/relationships">
+  <p:cSld>
+    <p:spTree>
+      <p:nvGrpSpPr>
+        <p:cNvPr id="1" name=""/>
+        <p:cNvGrpSpPr/>
+        <p:nvPr/>
+      </p:nvGrpSpPr>
+      <p:grpSpPr>
+        <a:xfrm>
+          <a:off x="0" y="0"/>
+          <a:ext cx="0" cy="0"/>
+          <a:chOff x="0" y="0"/>
+          <a:chExt cx="0" cy="0"/>
+        </a:xfrm>
+      </p:grpSpPr>
+      <p:sp>
+        <p:nvSpPr>
+          <p:cNvPr id="2" name="Slide Image Placeholder 1"/>
+          <p:cNvSpPr>
+            <a:spLocks noGrp="1"/>
+          </p:cNvSpPr>
+          <p:nvPr>
+            <p:ph type="sldImg" idx="2"/>
+          </p:nvPr>
+        </p:nvSpPr>
+        <p:spPr/>
+      </p:sp>
+      <p:sp>
+        <p:nvSpPr>
+          <p:cNvPr id="3" name="Notes Placeholder 2"/>
+          <p:cNvSpPr>
+            <a:spLocks noGrp="1"/>
+          </p:cNvSpPr>
+          <p:nvPr>
+            <p:ph type="body" idx="3" sz="quarter"/>
+          </p:nvPr>
+        </p:nvSpPr>
+        <p:spPr/>
+        <p:txBody>
+          <a:bodyPr/>
+          <a:lstStyle/>
+          <a:p>
+            <a:r>
+              <a:t>[60s]</a:t>
+            </a:r>
+          </a:p>
+          <a:p>
+            <a:r>
+              <a:t>I tested three strategies.</a:t>
+            </a:r>
+          </a:p>
+          <a:p>
+            <a:r>
+              <a:t>Inpainting masks part of a real photo and refills it. Same camera, same framing — no new geometry at all. It is the control, really.</a:t>
+            </a:r>
+          </a:p>
+          <a:p>
+            <a:r>
+              <a:t>Outpainting keeps the lens and enlarges the frame. The camera does not move; it just sees wider. That supplies peripheral content.</a:t>
+            </a:r>
+          </a:p>
+          <a:p>
+            <a:r>
+              <a:t>Pose-guided is the ambitious one. Estimate depth, warp the image to a new camera position I choose, and let diffusion fill the holes. It is the only one that invents a genuinely new viewpoint.</a:t>
+            </a:r>
+          </a:p>
+          <a:p>
+            <a:r>
+              <a:t>Each is generated at four ratios, three subset sizes, three seeds.</a:t>
+            </a:r>
+          </a:p>
+        </p:txBody>
+      </p:sp>
+      <p:sp>
+        <p:nvSpPr>
+          <p:cNvPr id="4" name="Slide Number Placeholder 3"/>
+          <p:cNvSpPr>
+            <a:spLocks noGrp="1"/>
+          </p:cNvSpPr>
+          <p:nvPr>
+            <p:ph type="sldNum" idx="5" sz="quarter"/>
+          </p:nvPr>
+        </p:nvSpPr>
+        <p:spPr/>
+      </p:sp>
+    </p:spTree>
+  </p:cSld>
+  <p:clrMapOvr>
+    <a:masterClrMapping/>
+  </p:clrMapOvr>
+</p:notes>
+</file>
+
+<file path=ppt/notesSlides/notesSlide5.xml><?xml version="1.0" encoding="utf-8"?>
+<p:notes xmlns:a="http://schemas.openxmlformats.org/drawingml/2006/main" xmlns:p="http://schemas.openxmlformats.org/presentationml/2006/main" xmlns:r="http://schemas.openxmlformats.org/officeDocument/2006/relationships">
+  <p:cSld>
+    <p:spTree>
+      <p:nvGrpSpPr>
+        <p:cNvPr id="1" name=""/>
+        <p:cNvGrpSpPr/>
+        <p:nvPr/>
+      </p:nvGrpSpPr>
+      <p:grpSpPr>
+        <a:xfrm>
+          <a:off x="0" y="0"/>
+          <a:ext cx="0" cy="0"/>
+          <a:chOff x="0" y="0"/>
+          <a:chExt cx="0" cy="0"/>
+        </a:xfrm>
+      </p:grpSpPr>
+      <p:sp>
+        <p:nvSpPr>
+          <p:cNvPr id="2" name="Slide Image Placeholder 1"/>
+          <p:cNvSpPr>
+            <a:spLocks noGrp="1"/>
+          </p:cNvSpPr>
+          <p:nvPr>
+            <p:ph type="sldImg" idx="2"/>
+          </p:nvPr>
+        </p:nvSpPr>
+        <p:spPr/>
+      </p:sp>
+      <p:sp>
+        <p:nvSpPr>
+          <p:cNvPr id="3" name="Notes Placeholder 2"/>
+          <p:cNvSpPr>
+            <a:spLocks noGrp="1"/>
+          </p:cNvSpPr>
+          <p:nvPr>
+            <p:ph type="body" idx="3" sz="quarter"/>
+          </p:nvPr>
+        </p:nvSpPr>
+        <p:spPr/>
+        <p:txBody>
+          <a:bodyPr/>
+          <a:lstStyle/>
+          <a:p>
+            <a:r>
+              <a:t>[55s]</a:t>
+            </a:r>
+          </a:p>
+          <a:p>
+            <a:r>
+              <a:t>The effects here are small, so the measurement has to be careful.</a:t>
+            </a:r>
+          </a:p>
+          <a:p>
+            <a:r>
+              <a:t>Every run of a scene is scored against byte-identical held-out images — I verify that by hash across all 236 runs.</a:t>
+            </a:r>
+          </a:p>
+          <a:p>
+            <a:r>
+              <a:t>Every augmented run is compared against its own seed's baseline. Which five photos you happen to draw matters enormously, and pairing cancels it.</a:t>
+            </a:r>
+          </a:p>
+          <a:p>
+            <a:r>
+              <a:t>And I measured the noise floor: the identical configuration run three times varies by 0.039 dB. So a 0.2 dB effect is real and a 0.03 dB effect is not.</a:t>
+            </a:r>
+          </a:p>
+        </p:txBody>
+      </p:sp>
+      <p:sp>
+        <p:nvSpPr>
+          <p:cNvPr id="4" name="Slide Number Placeholder 3"/>
+          <p:cNvSpPr>
+            <a:spLocks noGrp="1"/>
+          </p:cNvSpPr>
+          <p:nvPr>
+            <p:ph type="sldNum" idx="5" sz="quarter"/>
+          </p:nvPr>
+        </p:nvSpPr>
+        <p:spPr/>
+      </p:sp>
+    </p:spTree>
+  </p:cSld>
+  <p:clrMapOvr>
+    <a:masterClrMapping/>
+  </p:clrMapOvr>
+</p:notes>
+</file>
+
+<file path=ppt/notesSlides/notesSlide6.xml><?xml version="1.0" encoding="utf-8"?>
+<p:notes xmlns:a="http://schemas.openxmlformats.org/drawingml/2006/main" xmlns:p="http://schemas.openxmlformats.org/presentationml/2006/main" xmlns:r="http://schemas.openxmlformats.org/officeDocument/2006/relationships">
+  <p:cSld>
+    <p:spTree>
+      <p:nvGrpSpPr>
+        <p:cNvPr id="1" name=""/>
+        <p:cNvGrpSpPr/>
+        <p:nvPr/>
+      </p:nvGrpSpPr>
+      <p:grpSpPr>
+        <a:xfrm>
+          <a:off x="0" y="0"/>
+          <a:ext cx="0" cy="0"/>
+          <a:chOff x="0" y="0"/>
+          <a:chExt cx="0" cy="0"/>
+        </a:xfrm>
+      </p:grpSpPr>
+      <p:sp>
+        <p:nvSpPr>
+          <p:cNvPr id="2" name="Slide Image Placeholder 1"/>
+          <p:cNvSpPr>
+            <a:spLocks noGrp="1"/>
+          </p:cNvSpPr>
+          <p:nvPr>
+            <p:ph type="sldImg" idx="2"/>
+          </p:nvPr>
+        </p:nvSpPr>
+        <p:spPr/>
+      </p:sp>
+      <p:sp>
+        <p:nvSpPr>
+          <p:cNvPr id="3" name="Notes Placeholder 2"/>
+          <p:cNvSpPr>
+            <a:spLocks noGrp="1"/>
+          </p:cNvSpPr>
+          <p:nvPr>
+            <p:ph type="body" idx="3" sz="quarter"/>
+          </p:nvPr>
+        </p:nvSpPr>
+        <p:spPr/>
+        <p:txBody>
+          <a:bodyPr/>
+          <a:lstStyle/>
+          <a:p>
+            <a:r>
+              <a:t>[75s]</a:t>
+            </a:r>
+          </a:p>
+          <a:p>
+            <a:r>
+              <a:t>This is the main result.</a:t>
+            </a:r>
+          </a:p>
+          <a:p>
+            <a:r>
+              <a:t>Outpainting at the 200 percent ratio. At five real views it gains 0.285 dB. At ten it is zero. At twenty it LOSES 0.618.</a:t>
+            </a:r>
+          </a:p>
+          <a:p>
+            <a:r>
+              <a:t>The treatment is identical. The only thing that changed is how many real photographs it was added to.</a:t>
+            </a:r>
+          </a:p>
+          <a:p>
+            <a:r>
+              <a:t>PAUSE HERE. Let them look at the sign change.</a:t>
+            </a:r>
+          </a:p>
+          <a:p>
+            <a:r>
+              <a:t>For scale: five more real photographs are worth 1.9 dB. Augmentation buys you about a seventh of one photograph, and only while photographs are scarce.</a:t>
+            </a:r>
+          </a:p>
+        </p:txBody>
+      </p:sp>
+      <p:sp>
+        <p:nvSpPr>
+          <p:cNvPr id="4" name="Slide Number Placeholder 3"/>
+          <p:cNvSpPr>
+            <a:spLocks noGrp="1"/>
+          </p:cNvSpPr>
+          <p:nvPr>
+            <p:ph type="sldNum" idx="5" sz="quarter"/>
+          </p:nvPr>
+        </p:nvSpPr>
+        <p:spPr/>
+      </p:sp>
+    </p:spTree>
+  </p:cSld>
+  <p:clrMapOvr>
+    <a:masterClrMapping/>
+  </p:clrMapOvr>
+</p:notes>
+</file>
+
+<file path=ppt/notesSlides/notesSlide7.xml><?xml version="1.0" encoding="utf-8"?>
+<p:notes xmlns:a="http://schemas.openxmlformats.org/drawingml/2006/main" xmlns:p="http://schemas.openxmlformats.org/presentationml/2006/main" xmlns:r="http://schemas.openxmlformats.org/officeDocument/2006/relationships">
+  <p:cSld>
+    <p:spTree>
+      <p:nvGrpSpPr>
+        <p:cNvPr id="1" name=""/>
+        <p:cNvGrpSpPr/>
+        <p:nvPr/>
+      </p:nvGrpSpPr>
+      <p:grpSpPr>
+        <a:xfrm>
+          <a:off x="0" y="0"/>
+          <a:ext cx="0" cy="0"/>
+          <a:chOff x="0" y="0"/>
+          <a:chExt cx="0" cy="0"/>
+        </a:xfrm>
+      </p:grpSpPr>
+      <p:sp>
+        <p:nvSpPr>
+          <p:cNvPr id="2" name="Slide Image Placeholder 1"/>
+          <p:cNvSpPr>
+            <a:spLocks noGrp="1"/>
+          </p:cNvSpPr>
+          <p:nvPr>
+            <p:ph type="sldImg" idx="2"/>
+          </p:nvPr>
+        </p:nvSpPr>
+        <p:spPr/>
+      </p:sp>
+      <p:sp>
+        <p:nvSpPr>
+          <p:cNvPr id="3" name="Notes Placeholder 2"/>
+          <p:cNvSpPr>
+            <a:spLocks noGrp="1"/>
+          </p:cNvSpPr>
+          <p:nvPr>
+            <p:ph type="body" idx="3" sz="quarter"/>
+          </p:nvPr>
+        </p:nvSpPr>
+        <p:spPr/>
+        <p:txBody>
+          <a:bodyPr/>
+          <a:lstStyle/>
+          <a:p>
+            <a:r>
+              <a:t>[40s]</a:t>
+            </a:r>
+          </a:p>
+          <a:p>
+            <a:r>
+              <a:t>The same thing visually. Left pair is five views, right pair is twenty.</a:t>
+            </a:r>
+          </a:p>
+          <a:p>
+            <a:r>
+              <a:t>One caution on this figure: per-view effects scatter several dB either side of the average. So I picked the views closest to the mean effect and printed the per-view number on each. Three arbitrary views can contradict the finding they are supposed to illustrate.</a:t>
+            </a:r>
+          </a:p>
+        </p:txBody>
+      </p:sp>
+      <p:sp>
+        <p:nvSpPr>
+          <p:cNvPr id="4" name="Slide Number Placeholder 3"/>
+          <p:cNvSpPr>
+            <a:spLocks noGrp="1"/>
+          </p:cNvSpPr>
+          <p:nvPr>
+            <p:ph type="sldNum" idx="5" sz="quarter"/>
+          </p:nvPr>
+        </p:nvSpPr>
+        <p:spPr/>
+      </p:sp>
+    </p:spTree>
+  </p:cSld>
+  <p:clrMapOvr>
+    <a:masterClrMapping/>
+  </p:clrMapOvr>
+</p:notes>
+</file>
+
+<file path=ppt/notesSlides/notesSlide8.xml><?xml version="1.0" encoding="utf-8"?>
+<p:notes xmlns:a="http://schemas.openxmlformats.org/drawingml/2006/main" xmlns:p="http://schemas.openxmlformats.org/presentationml/2006/main" xmlns:r="http://schemas.openxmlformats.org/officeDocument/2006/relationships">
+  <p:cSld>
+    <p:spTree>
+      <p:nvGrpSpPr>
+        <p:cNvPr id="1" name=""/>
+        <p:cNvGrpSpPr/>
+        <p:nvPr/>
+      </p:nvGrpSpPr>
+      <p:grpSpPr>
+        <a:xfrm>
+          <a:off x="0" y="0"/>
+          <a:ext cx="0" cy="0"/>
+          <a:chOff x="0" y="0"/>
+          <a:chExt cx="0" cy="0"/>
+        </a:xfrm>
+      </p:grpSpPr>
+      <p:sp>
+        <p:nvSpPr>
+          <p:cNvPr id="2" name="Slide Image Placeholder 1"/>
+          <p:cNvSpPr>
+            <a:spLocks noGrp="1"/>
+          </p:cNvSpPr>
+          <p:nvPr>
+            <p:ph type="sldImg" idx="2"/>
+          </p:nvPr>
+        </p:nvSpPr>
+        <p:spPr/>
+      </p:sp>
+      <p:sp>
+        <p:nvSpPr>
+          <p:cNvPr id="3" name="Notes Placeholder 2"/>
+          <p:cNvSpPr>
+            <a:spLocks noGrp="1"/>
+          </p:cNvSpPr>
+          <p:nvPr>
+            <p:ph type="body" idx="3" sz="quarter"/>
+          </p:nvPr>
+        </p:nvSpPr>
+        <p:spPr/>
+        <p:txBody>
+          <a:bodyPr/>
+          <a:lstStyle/>
+          <a:p>
+            <a:r>
+              <a:t>[45s]</a:t>
+            </a:r>
+          </a:p>
+          <a:p>
+            <a:r>
+              <a:t>The obvious worry is that this is one scene's quirk. So I repeated the sweep on an indoor room from a different dataset — different capture geometry, different scale.</a:t>
+            </a:r>
+          </a:p>
+          <a:p>
+            <a:r>
+              <a:t>Same sign flip. And indoors the effect is stronger at five views.</a:t>
+            </a:r>
+          </a:p>
+          <a:p>
+            <a:r>
+              <a:t>Note the third number: the baselines scatter 0.52 dB between seeds indoors, against 0.07 outdoors. Which five views you draw matters far more in a room. Without the paired design I could not have resolved the effect at all.</a:t>
+            </a:r>
+          </a:p>
+        </p:txBody>
+      </p:sp>
+      <p:sp>
+        <p:nvSpPr>
+          <p:cNvPr id="4" name="Slide Number Placeholder 3"/>
+          <p:cNvSpPr>
+            <a:spLocks noGrp="1"/>
+          </p:cNvSpPr>
+          <p:nvPr>
+            <p:ph type="sldNum" idx="5" sz="quarter"/>
+          </p:nvPr>
+        </p:nvSpPr>
+        <p:spPr/>
+      </p:sp>
+    </p:spTree>
+  </p:cSld>
+  <p:clrMapOvr>
+    <a:masterClrMapping/>
+  </p:clrMapOvr>
+</p:notes>
+</file>
+
+<file path=ppt/notesSlides/notesSlide9.xml><?xml version="1.0" encoding="utf-8"?>
+<p:notes xmlns:a="http://schemas.openxmlformats.org/drawingml/2006/main" xmlns:p="http://schemas.openxmlformats.org/presentationml/2006/main" xmlns:r="http://schemas.openxmlformats.org/officeDocument/2006/relationships">
+  <p:cSld>
+    <p:spTree>
+      <p:nvGrpSpPr>
+        <p:cNvPr id="1" name=""/>
+        <p:cNvGrpSpPr/>
+        <p:nvPr/>
+      </p:nvGrpSpPr>
+      <p:grpSpPr>
+        <a:xfrm>
+          <a:off x="0" y="0"/>
+          <a:ext cx="0" cy="0"/>
+          <a:chOff x="0" y="0"/>
+          <a:chExt cx="0" cy="0"/>
+        </a:xfrm>
+      </p:grpSpPr>
+      <p:sp>
+        <p:nvSpPr>
+          <p:cNvPr id="2" name="Slide Image Placeholder 1"/>
+          <p:cNvSpPr>
+            <a:spLocks noGrp="1"/>
+          </p:cNvSpPr>
+          <p:nvPr>
+            <p:ph type="sldImg" idx="2"/>
+          </p:nvPr>
+        </p:nvSpPr>
+        <p:spPr/>
+      </p:sp>
+      <p:sp>
+        <p:nvSpPr>
+          <p:cNvPr id="3" name="Notes Placeholder 2"/>
+          <p:cNvSpPr>
+            <a:spLocks noGrp="1"/>
+          </p:cNvSpPr>
+          <p:nvPr>
+            <p:ph type="body" idx="3" sz="quarter"/>
+          </p:nvPr>
+        </p:nvSpPr>
+        <p:spPr/>
+        <p:txBody>
+          <a:bodyPr/>
+          <a:lstStyle/>
+          <a:p>
+            <a:r>
+              <a:t>[65s]</a:t>
+            </a:r>
+          </a:p>
+          <a:p>
+            <a:r>
+              <a:t>Here is why the sign flips.</a:t>
+            </a:r>
+          </a:p>
+          <a:p>
+            <a:r>
+              <a:t>Every synthetic view gives you two things at once. Coverage — some part of the scene no real camera saw. And inconsistency — it is invented, so it disagrees with the real photographs.</a:t>
+            </a:r>
+          </a:p>
+          <a:p>
+            <a:r>
+              <a:t>Coverage DECAYS as you add real views. You have already seen that area.</a:t>
+            </a:r>
+          </a:p>
+          <a:p>
+            <a:r>
+              <a:t>Inconsistency does NOT decay. A contradiction is just as harmful at twenty views as at five. Arguably worse, because now it contradicts a better-determined geometry.</a:t>
+            </a:r>
+          </a:p>
+          <a:p>
+            <a:r>
+              <a:t>A shrinking benefit plus a constant cost gives you a sign change. That is the whole mechanism.</a:t>
+            </a:r>
+          </a:p>
+          <a:p>
+            <a:r>
+              <a:t>But that is just a story. So I made it predict things that could fail.</a:t>
+            </a:r>
+          </a:p>
+        </p:txBody>
+      </p:sp>
+      <p:sp>
+        <p:nvSpPr>
+          <p:cNvPr id="4" name="Slide Number Placeholder 3"/>
+          <p:cNvSpPr>
+            <a:spLocks noGrp="1"/>
+          </p:cNvSpPr>
+          <p:nvPr>
+            <p:ph type="sldNum" idx="5" sz="quarter"/>
+          </p:nvPr>
+        </p:nvSpPr>
+        <p:spPr/>
+      </p:sp>
+    </p:spTree>
+  </p:cSld>
+  <p:clrMapOvr>
+    <a:masterClrMapping/>
+  </p:clrMapOvr>
+</p:notes>
 </file>
 
 <file path=ppt/slideLayouts/slideLayout1.xml><?xml version="1.0" encoding="utf-8"?>
@@ -7075,4 +8700,324 @@
   </a:objectDefaults>
   <a:extraClrSchemeLst/>
 </a:theme>
+</file>
+
+<file path=ppt/theme/theme2.xml><?xml version="1.0" encoding="utf-8"?>
+<a:theme xmlns:a="http://schemas.openxmlformats.org/drawingml/2006/main" name="Office Theme">
+  <a:themeElements>
+    <a:clrScheme name="Office">
+      <a:dk1>
+        <a:sysClr val="windowText" lastClr="000000"/>
+      </a:dk1>
+      <a:lt1>
+        <a:sysClr val="window" lastClr="FFFFFF"/>
+      </a:lt1>
+      <a:dk2>
+        <a:srgbClr val="1F497D"/>
+      </a:dk2>
+      <a:lt2>
+        <a:srgbClr val="EEECE1"/>
+      </a:lt2>
+      <a:accent1>
+        <a:srgbClr val="4F81BD"/>
+      </a:accent1>
+      <a:accent2>
+        <a:srgbClr val="C0504D"/>
+      </a:accent2>
+      <a:accent3>
+        <a:srgbClr val="9BBB59"/>
+      </a:accent3>
+      <a:accent4>
+        <a:srgbClr val="8064A2"/>
+      </a:accent4>
+      <a:accent5>
+        <a:srgbClr val="4BACC6"/>
+      </a:accent5>
+      <a:accent6>
+        <a:srgbClr val="F79646"/>
+      </a:accent6>
+      <a:hlink>
+        <a:srgbClr val="0000FF"/>
+      </a:hlink>
+      <a:folHlink>
+        <a:srgbClr val="800080"/>
+      </a:folHlink>
+    </a:clrScheme>
+    <a:fontScheme name="Office">
+      <a:majorFont>
+        <a:latin typeface="Calibri"/>
+        <a:ea typeface=""/>
+        <a:cs typeface=""/>
+        <a:font script="Jpan" typeface="ＭＳ Ｐゴシック"/>
+        <a:font script="Hang" typeface="맑은 고딕"/>
+        <a:font script="Hans" typeface="宋体"/>
+        <a:font script="Hant" typeface="新細明體"/>
+        <a:font script="Arab" typeface="Times New Roman"/>
+        <a:font script="Hebr" typeface="Times New Roman"/>
+        <a:font script="Thai" typeface="Angsana New"/>
+        <a:font script="Ethi" typeface="Nyala"/>
+        <a:font script="Beng" typeface="Vrinda"/>
+        <a:font script="Gujr" typeface="Shruti"/>
+        <a:font script="Khmr" typeface="MoolBoran"/>
+        <a:font script="Knda" typeface="Tunga"/>
+        <a:font script="Guru" typeface="Raavi"/>
+        <a:font script="Cans" typeface="Euphemia"/>
+        <a:font script="Cher" typeface="Plantagenet Cherokee"/>
+        <a:font script="Yiii" typeface="Microsoft Yi Baiti"/>
+        <a:font script="Tibt" typeface="Microsoft Himalaya"/>
+        <a:font script="Thaa" typeface="MV Boli"/>
+        <a:font script="Deva" typeface="Mangal"/>
+        <a:font script="Telu" typeface="Gautami"/>
+        <a:font script="Taml" typeface="Latha"/>
+        <a:font script="Syrc" typeface="Estrangelo Edessa"/>
+        <a:font script="Orya" typeface="Kalinga"/>
+        <a:font script="Mlym" typeface="Kartika"/>
+        <a:font script="Laoo" typeface="DokChampa"/>
+        <a:font script="Sinh" typeface="Iskoola Pota"/>
+        <a:font script="Mong" typeface="Mongolian Baiti"/>
+        <a:font script="Viet" typeface="Times New Roman"/>
+        <a:font script="Uigh" typeface="Microsoft Uighur"/>
+        <a:font script="Geor" typeface="Sylfaen"/>
+      </a:majorFont>
+      <a:minorFont>
+        <a:latin typeface="Calibri"/>
+        <a:ea typeface=""/>
+        <a:cs typeface=""/>
+        <a:font script="Jpan" typeface="ＭＳ Ｐゴシック"/>
+        <a:font script="Hang" typeface="맑은 고딕"/>
+        <a:font script="Hans" typeface="宋体"/>
+        <a:font script="Hant" typeface="新細明體"/>
+        <a:font script="Arab" typeface="Arial"/>
+        <a:font script="Hebr" typeface="Arial"/>
+        <a:font script="Thai" typeface="Cordia New"/>
+        <a:font script="Ethi" typeface="Nyala"/>
+        <a:font script="Beng" typeface="Vrinda"/>
+        <a:font script="Gujr" typeface="Shruti"/>
+        <a:font script="Khmr" typeface="DaunPenh"/>
+        <a:font script="Knda" typeface="Tunga"/>
+        <a:font script="Guru" typeface="Raavi"/>
+        <a:font script="Cans" typeface="Euphemia"/>
+        <a:font script="Cher" typeface="Plantagenet Cherokee"/>
+        <a:font script="Yiii" typeface="Microsoft Yi Baiti"/>
+        <a:font script="Tibt" typeface="Microsoft Himalaya"/>
+        <a:font script="Thaa" typeface="MV Boli"/>
+        <a:font script="Deva" typeface="Mangal"/>
+        <a:font script="Telu" typeface="Gautami"/>
+        <a:font script="Taml" typeface="Latha"/>
+        <a:font script="Syrc" typeface="Estrangelo Edessa"/>
+        <a:font script="Orya" typeface="Kalinga"/>
+        <a:font script="Mlym" typeface="Kartika"/>
+        <a:font script="Laoo" typeface="DokChampa"/>
+        <a:font script="Sinh" typeface="Iskoola Pota"/>
+        <a:font script="Mong" typeface="Mongolian Baiti"/>
+        <a:font script="Viet" typeface="Arial"/>
+        <a:font script="Uigh" typeface="Microsoft Uighur"/>
+        <a:font script="Geor" typeface="Sylfaen"/>
+      </a:minorFont>
+    </a:fontScheme>
+    <a:fmtScheme name="Office">
+      <a:fillStyleLst>
+        <a:solidFill>
+          <a:schemeClr val="phClr"/>
+        </a:solidFill>
+        <a:gradFill rotWithShape="1">
+          <a:gsLst>
+            <a:gs pos="0">
+              <a:schemeClr val="phClr">
+                <a:tint val="50000"/>
+                <a:satMod val="300000"/>
+              </a:schemeClr>
+            </a:gs>
+            <a:gs pos="35000">
+              <a:schemeClr val="phClr">
+                <a:tint val="37000"/>
+                <a:satMod val="300000"/>
+              </a:schemeClr>
+            </a:gs>
+            <a:gs pos="100000">
+              <a:schemeClr val="phClr">
+                <a:tint val="15000"/>
+                <a:satMod val="350000"/>
+              </a:schemeClr>
+            </a:gs>
+          </a:gsLst>
+          <a:lin ang="16200000" scaled="1"/>
+        </a:gradFill>
+        <a:gradFill rotWithShape="1">
+          <a:gsLst>
+            <a:gs pos="0">
+              <a:schemeClr val="phClr">
+                <a:tint val="100000"/>
+                <a:shade val="100000"/>
+                <a:satMod val="130000"/>
+              </a:schemeClr>
+            </a:gs>
+            <a:gs pos="100000">
+              <a:schemeClr val="phClr">
+                <a:tint val="50000"/>
+                <a:shade val="100000"/>
+                <a:satMod val="350000"/>
+              </a:schemeClr>
+            </a:gs>
+          </a:gsLst>
+          <a:lin ang="16200000" scaled="0"/>
+        </a:gradFill>
+      </a:fillStyleLst>
+      <a:lnStyleLst>
+        <a:ln w="9525" cap="flat" cmpd="sng" algn="ctr">
+          <a:solidFill>
+            <a:schemeClr val="phClr">
+              <a:shade val="95000"/>
+              <a:satMod val="105000"/>
+            </a:schemeClr>
+          </a:solidFill>
+          <a:prstDash val="solid"/>
+        </a:ln>
+        <a:ln w="25400" cap="flat" cmpd="sng" algn="ctr">
+          <a:solidFill>
+            <a:schemeClr val="phClr"/>
+          </a:solidFill>
+          <a:prstDash val="solid"/>
+        </a:ln>
+        <a:ln w="38100" cap="flat" cmpd="sng" algn="ctr">
+          <a:solidFill>
+            <a:schemeClr val="phClr"/>
+          </a:solidFill>
+          <a:prstDash val="solid"/>
+        </a:ln>
+      </a:lnStyleLst>
+      <a:effectStyleLst>
+        <a:effectStyle>
+          <a:effectLst>
+            <a:outerShdw blurRad="40000" dist="20000" dir="5400000" rotWithShape="0">
+              <a:srgbClr val="000000">
+                <a:alpha val="38000"/>
+              </a:srgbClr>
+            </a:outerShdw>
+          </a:effectLst>
+        </a:effectStyle>
+        <a:effectStyle>
+          <a:effectLst>
+            <a:outerShdw blurRad="40000" dist="23000" dir="5400000" rotWithShape="0">
+              <a:srgbClr val="000000">
+                <a:alpha val="35000"/>
+              </a:srgbClr>
+            </a:outerShdw>
+          </a:effectLst>
+        </a:effectStyle>
+        <a:effectStyle>
+          <a:effectLst>
+            <a:outerShdw blurRad="40000" dist="23000" dir="5400000" rotWithShape="0">
+              <a:srgbClr val="000000">
+                <a:alpha val="35000"/>
+              </a:srgbClr>
+            </a:outerShdw>
+          </a:effectLst>
+          <a:scene3d>
+            <a:camera prst="orthographicFront">
+              <a:rot lat="0" lon="0" rev="0"/>
+            </a:camera>
+            <a:lightRig rig="threePt" dir="t">
+              <a:rot lat="0" lon="0" rev="1200000"/>
+            </a:lightRig>
+          </a:scene3d>
+          <a:sp3d>
+            <a:bevelT w="63500" h="25400"/>
+          </a:sp3d>
+        </a:effectStyle>
+      </a:effectStyleLst>
+      <a:bgFillStyleLst>
+        <a:solidFill>
+          <a:schemeClr val="phClr"/>
+        </a:solidFill>
+        <a:gradFill rotWithShape="1">
+          <a:gsLst>
+            <a:gs pos="0">
+              <a:schemeClr val="phClr">
+                <a:tint val="40000"/>
+                <a:satMod val="350000"/>
+              </a:schemeClr>
+            </a:gs>
+            <a:gs pos="40000">
+              <a:schemeClr val="phClr">
+                <a:tint val="45000"/>
+                <a:shade val="99000"/>
+                <a:satMod val="350000"/>
+              </a:schemeClr>
+            </a:gs>
+            <a:gs pos="100000">
+              <a:schemeClr val="phClr">
+                <a:shade val="20000"/>
+                <a:satMod val="255000"/>
+              </a:schemeClr>
+            </a:gs>
+          </a:gsLst>
+          <a:path path="circle">
+            <a:fillToRect l="50000" t="-80000" r="50000" b="180000"/>
+          </a:path>
+        </a:gradFill>
+        <a:gradFill rotWithShape="1">
+          <a:gsLst>
+            <a:gs pos="0">
+              <a:schemeClr val="phClr">
+                <a:tint val="80000"/>
+                <a:satMod val="300000"/>
+              </a:schemeClr>
+            </a:gs>
+            <a:gs pos="100000">
+              <a:schemeClr val="phClr">
+                <a:shade val="30000"/>
+                <a:satMod val="200000"/>
+              </a:schemeClr>
+            </a:gs>
+          </a:gsLst>
+          <a:path path="circle">
+            <a:fillToRect l="50000" t="50000" r="50000" b="50000"/>
+          </a:path>
+        </a:gradFill>
+      </a:bgFillStyleLst>
+    </a:fmtScheme>
+  </a:themeElements>
+  <a:objectDefaults>
+    <a:spDef>
+      <a:spPr/>
+      <a:bodyPr/>
+      <a:lstStyle/>
+      <a:style>
+        <a:lnRef idx="1">
+          <a:schemeClr val="accent1"/>
+        </a:lnRef>
+        <a:fillRef idx="3">
+          <a:schemeClr val="accent1"/>
+        </a:fillRef>
+        <a:effectRef idx="2">
+          <a:schemeClr val="accent1"/>
+        </a:effectRef>
+        <a:fontRef idx="minor">
+          <a:schemeClr val="lt1"/>
+        </a:fontRef>
+      </a:style>
+    </a:spDef>
+    <a:lnDef>
+      <a:spPr/>
+      <a:bodyPr/>
+      <a:lstStyle/>
+      <a:style>
+        <a:lnRef idx="2">
+          <a:schemeClr val="accent1"/>
+        </a:lnRef>
+        <a:fillRef idx="0">
+          <a:schemeClr val="accent1"/>
+        </a:fillRef>
+        <a:effectRef idx="1">
+          <a:schemeClr val="accent1"/>
+        </a:effectRef>
+        <a:fontRef idx="minor">
+          <a:schemeClr val="tx1"/>
+        </a:fontRef>
+      </a:style>
+    </a:lnDef>
+  </a:objectDefaults>
+  <a:extraClrSchemeLst/>
+</a:theme>
 </file>
</xml_diff>